<commit_message>
docs: atualiza apresentacao do seminario
</commit_message>
<xml_diff>
--- a/5-semestre/programacao-web/n1 - tecnologias web/docs/Apresentação N1 - Nextjs.pptx
+++ b/5-semestre/programacao-web/n1 - tecnologias web/docs/Apresentação N1 - Nextjs.pptx
@@ -5,7 +5,7 @@
     <p:sldMasterId id="2147483648" r:id="rId1"/>
   </p:sldMasterIdLst>
   <p:notesMasterIdLst>
-    <p:notesMasterId r:id="rId14"/>
+    <p:notesMasterId r:id="rId13"/>
   </p:notesMasterIdLst>
   <p:sldIdLst>
     <p:sldId id="256" r:id="rId2"/>
@@ -18,8 +18,7 @@
     <p:sldId id="263" r:id="rId9"/>
     <p:sldId id="264" r:id="rId10"/>
     <p:sldId id="265" r:id="rId11"/>
-    <p:sldId id="266" r:id="rId12"/>
-    <p:sldId id="267" r:id="rId13"/>
+    <p:sldId id="267" r:id="rId12"/>
   </p:sldIdLst>
   <p:sldSz cx="12192000" cy="6858000"/>
   <p:notesSz cx="6858000" cy="12192000"/>
@@ -482,90 +481,6 @@
             <a:fld id="{F7021451-1387-4CA6-816F-3879F97B5CBC}" type="slidenum">
               <a:rPr lang="en-US"/>
               <a:t>11</a:t>
-            </a:fld>
-            <a:endParaRPr lang="en-US"/>
-          </a:p>
-        </p:txBody>
-      </p:sp>
-    </p:spTree>
-    <p:extLst>
-      <p:ext uri="{BB962C8B-B14F-4D97-AF65-F5344CB8AC3E}">
-        <p14:creationId xmlns:p14="http://schemas.microsoft.com/office/powerpoint/2010/main" val="1024086991"/>
-      </p:ext>
-    </p:extLst>
-  </p:cSld>
-  <p:clrMapOvr>
-    <a:masterClrMapping/>
-  </p:clrMapOvr>
-</p:notes>
-</file>
-
-<file path=ppt/notesSlides/notesSlide12.xml><?xml version="1.0" encoding="utf-8"?>
-<p:notes xmlns:a="http://schemas.openxmlformats.org/drawingml/2006/main" xmlns:r="http://schemas.openxmlformats.org/officeDocument/2006/relationships" xmlns:p="http://schemas.openxmlformats.org/presentationml/2006/main">
-  <p:cSld>
-    <p:spTree>
-      <p:nvGrpSpPr>
-        <p:cNvPr id="1" name=""/>
-        <p:cNvGrpSpPr/>
-        <p:nvPr/>
-      </p:nvGrpSpPr>
-      <p:grpSpPr>
-        <a:xfrm>
-          <a:off x="0" y="0"/>
-          <a:ext cx="0" cy="0"/>
-          <a:chOff x="0" y="0"/>
-          <a:chExt cx="0" cy="0"/>
-        </a:xfrm>
-      </p:grpSpPr>
-      <p:sp>
-        <p:nvSpPr>
-          <p:cNvPr id="2" name="Slide Image Placeholder 1"/>
-          <p:cNvSpPr>
-            <a:spLocks noGrp="1" noRot="1" noChangeAspect="1"/>
-          </p:cNvSpPr>
-          <p:nvPr>
-            <p:ph type="sldImg"/>
-          </p:nvPr>
-        </p:nvSpPr>
-        <p:spPr/>
-      </p:sp>
-      <p:sp>
-        <p:nvSpPr>
-          <p:cNvPr id="3" name="Notes Placeholder 2"/>
-          <p:cNvSpPr>
-            <a:spLocks noGrp="1"/>
-          </p:cNvSpPr>
-          <p:nvPr>
-            <p:ph type="body" idx="1"/>
-          </p:nvPr>
-        </p:nvSpPr>
-        <p:spPr/>
-        <p:txBody>
-          <a:bodyPr/>
-          <a:lstStyle/>
-          <a:p>
-            <a:endParaRPr lang="en-US" dirty="0"/>
-          </a:p>
-        </p:txBody>
-      </p:sp>
-      <p:sp>
-        <p:nvSpPr>
-          <p:cNvPr id="4" name="Slide Number Placeholder 3"/>
-          <p:cNvSpPr>
-            <a:spLocks noGrp="1"/>
-          </p:cNvSpPr>
-          <p:nvPr>
-            <p:ph type="sldNum" sz="quarter" idx="10"/>
-          </p:nvPr>
-        </p:nvSpPr>
-        <p:spPr/>
-        <p:txBody>
-          <a:bodyPr/>
-          <a:lstStyle/>
-          <a:p>
-            <a:fld id="{F7021451-1387-4CA6-816F-3879F97B5CBC}" type="slidenum">
-              <a:rPr lang="en-US"/>
-              <a:t>12</a:t>
             </a:fld>
             <a:endParaRPr lang="en-US"/>
           </a:p>
@@ -2845,549 +2760,6 @@
 </file>
 
 <file path=ppt/slides/slide11.xml><?xml version="1.0" encoding="utf-8"?>
-<p:sld xmlns:a="http://schemas.openxmlformats.org/drawingml/2006/main" xmlns:r="http://schemas.openxmlformats.org/officeDocument/2006/relationships" xmlns:p="http://schemas.openxmlformats.org/presentationml/2006/main">
-  <p:cSld name="Slide 11">
-    <p:bg>
-      <p:bgPr>
-        <a:solidFill>
-          <a:srgbClr val="FFFFFF"/>
-        </a:solidFill>
-        <a:effectLst/>
-      </p:bgPr>
-    </p:bg>
-    <p:spTree>
-      <p:nvGrpSpPr>
-        <p:cNvPr id="1" name=""/>
-        <p:cNvGrpSpPr/>
-        <p:nvPr/>
-      </p:nvGrpSpPr>
-      <p:grpSpPr>
-        <a:xfrm>
-          <a:off x="0" y="0"/>
-          <a:ext cx="0" cy="0"/>
-          <a:chOff x="0" y="0"/>
-          <a:chExt cx="0" cy="0"/>
-        </a:xfrm>
-      </p:grpSpPr>
-      <p:sp>
-        <p:nvSpPr>
-          <p:cNvPr id="2" name="Text 0"/>
-          <p:cNvSpPr/>
-          <p:nvPr/>
-        </p:nvSpPr>
-        <p:spPr>
-          <a:xfrm>
-            <a:off x="548640" y="384048"/>
-            <a:ext cx="11091672" cy="777240"/>
-          </a:xfrm>
-          <a:prstGeom prst="rect">
-            <a:avLst/>
-          </a:prstGeom>
-          <a:noFill/>
-          <a:ln/>
-        </p:spPr>
-        <p:txBody>
-          <a:bodyPr wrap="square" lIns="0" tIns="0" rIns="0" bIns="0" rtlCol="0" anchor="ctr"/>
-          <a:lstStyle/>
-          <a:p>
-            <a:pPr marL="0" indent="0">
-              <a:buNone/>
-            </a:pPr>
-            <a:r>
-              <a:rPr lang="en-US" sz="3200" b="1" dirty="0">
-                <a:solidFill>
-                  <a:srgbClr val="1E293B"/>
-                </a:solidFill>
-                <a:latin typeface="Calibri" pitchFamily="34" charset="0"/>
-                <a:ea typeface="Calibri" pitchFamily="34" charset="-122"/>
-                <a:cs typeface="Calibri" pitchFamily="34" charset="-120"/>
-              </a:rPr>
-              <a:t>Plano B</a:t>
-            </a:r>
-            <a:endParaRPr lang="en-US" sz="3200" dirty="0"/>
-          </a:p>
-        </p:txBody>
-      </p:sp>
-      <p:sp>
-        <p:nvSpPr>
-          <p:cNvPr id="3" name="Text 1"/>
-          <p:cNvSpPr/>
-          <p:nvPr/>
-        </p:nvSpPr>
-        <p:spPr>
-          <a:xfrm>
-            <a:off x="548640" y="1078992"/>
-            <a:ext cx="11091672" cy="457200"/>
-          </a:xfrm>
-          <a:prstGeom prst="rect">
-            <a:avLst/>
-          </a:prstGeom>
-          <a:noFill/>
-          <a:ln/>
-        </p:spPr>
-        <p:txBody>
-          <a:bodyPr wrap="square" lIns="0" tIns="0" rIns="0" bIns="0" rtlCol="0" anchor="ctr"/>
-          <a:lstStyle/>
-          <a:p>
-            <a:pPr marL="0" indent="0">
-              <a:buNone/>
-            </a:pPr>
-            <a:r>
-              <a:rPr lang="en-US" sz="1500" dirty="0">
-                <a:solidFill>
-                  <a:srgbClr val="64748B"/>
-                </a:solidFill>
-                <a:latin typeface="Calibri" pitchFamily="34" charset="0"/>
-                <a:ea typeface="Calibri" pitchFamily="34" charset="-122"/>
-                <a:cs typeface="Calibri" pitchFamily="34" charset="-120"/>
-              </a:rPr>
-              <a:t>Se o live coding falhar, a apresentação continua</a:t>
-            </a:r>
-            <a:endParaRPr lang="en-US" sz="1500" dirty="0"/>
-          </a:p>
-        </p:txBody>
-      </p:sp>
-      <p:sp>
-        <p:nvSpPr>
-          <p:cNvPr id="4" name="Text 2"/>
-          <p:cNvSpPr/>
-          <p:nvPr/>
-        </p:nvSpPr>
-        <p:spPr>
-          <a:xfrm>
-            <a:off x="548640" y="6473952"/>
-            <a:ext cx="7315200" cy="274320"/>
-          </a:xfrm>
-          <a:prstGeom prst="rect">
-            <a:avLst/>
-          </a:prstGeom>
-          <a:noFill/>
-          <a:ln/>
-        </p:spPr>
-        <p:txBody>
-          <a:bodyPr wrap="square" lIns="0" tIns="0" rIns="0" bIns="0" rtlCol="0" anchor="ctr"/>
-          <a:lstStyle/>
-          <a:p>
-            <a:pPr marL="0" indent="0">
-              <a:buNone/>
-            </a:pPr>
-            <a:r>
-              <a:rPr lang="en-US" sz="900" dirty="0">
-                <a:solidFill>
-                  <a:srgbClr val="64748B"/>
-                </a:solidFill>
-                <a:latin typeface="Calibri" pitchFamily="34" charset="0"/>
-                <a:ea typeface="Calibri" pitchFamily="34" charset="-122"/>
-                <a:cs typeface="Calibri" pitchFamily="34" charset="-120"/>
-              </a:rPr>
-              <a:t>Seminário Tecnologias WEB · Next.js: SSR e Roteamento</a:t>
-            </a:r>
-            <a:endParaRPr lang="en-US" sz="900" dirty="0"/>
-          </a:p>
-        </p:txBody>
-      </p:sp>
-      <p:sp>
-        <p:nvSpPr>
-          <p:cNvPr id="5" name="Text 3"/>
-          <p:cNvSpPr/>
-          <p:nvPr/>
-        </p:nvSpPr>
-        <p:spPr>
-          <a:xfrm>
-            <a:off x="11183112" y="6473952"/>
-            <a:ext cx="457200" cy="274320"/>
-          </a:xfrm>
-          <a:prstGeom prst="rect">
-            <a:avLst/>
-          </a:prstGeom>
-          <a:noFill/>
-          <a:ln/>
-        </p:spPr>
-        <p:txBody>
-          <a:bodyPr wrap="square" lIns="0" tIns="0" rIns="0" bIns="0" rtlCol="0" anchor="ctr"/>
-          <a:lstStyle/>
-          <a:p>
-            <a:pPr marL="0" indent="0" algn="r">
-              <a:buNone/>
-            </a:pPr>
-            <a:r>
-              <a:rPr lang="en-US" sz="900" dirty="0">
-                <a:solidFill>
-                  <a:srgbClr val="64748B"/>
-                </a:solidFill>
-                <a:latin typeface="Calibri" pitchFamily="34" charset="0"/>
-                <a:ea typeface="Calibri" pitchFamily="34" charset="-122"/>
-                <a:cs typeface="Calibri" pitchFamily="34" charset="-120"/>
-              </a:rPr>
-              <a:t>11</a:t>
-            </a:r>
-            <a:endParaRPr lang="en-US" sz="900" dirty="0"/>
-          </a:p>
-        </p:txBody>
-      </p:sp>
-      <p:sp>
-        <p:nvSpPr>
-          <p:cNvPr id="6" name="Shape 4"/>
-          <p:cNvSpPr/>
-          <p:nvPr/>
-        </p:nvSpPr>
-        <p:spPr>
-          <a:xfrm>
-            <a:off x="548640" y="1920240"/>
-            <a:ext cx="5440680" cy="3291840"/>
-          </a:xfrm>
-          <a:prstGeom prst="roundRect">
-            <a:avLst>
-              <a:gd name="adj" fmla="val 2500"/>
-            </a:avLst>
-          </a:prstGeom>
-          <a:solidFill>
-            <a:srgbClr val="F1F5F9"/>
-          </a:solidFill>
-          <a:ln w="12700">
-            <a:solidFill>
-              <a:srgbClr val="E2E8F0"/>
-            </a:solidFill>
-            <a:prstDash val="solid"/>
-          </a:ln>
-        </p:spPr>
-        <p:txBody>
-          <a:bodyPr/>
-          <a:lstStyle/>
-          <a:p>
-            <a:endParaRPr lang="pt-BR"/>
-          </a:p>
-        </p:txBody>
-      </p:sp>
-      <p:sp>
-        <p:nvSpPr>
-          <p:cNvPr id="7" name="Text 5"/>
-          <p:cNvSpPr/>
-          <p:nvPr/>
-        </p:nvSpPr>
-        <p:spPr>
-          <a:xfrm>
-            <a:off x="914400" y="2240280"/>
-            <a:ext cx="4663440" cy="457200"/>
-          </a:xfrm>
-          <a:prstGeom prst="rect">
-            <a:avLst/>
-          </a:prstGeom>
-          <a:noFill/>
-          <a:ln/>
-        </p:spPr>
-        <p:txBody>
-          <a:bodyPr wrap="square" lIns="0" tIns="0" rIns="0" bIns="0" rtlCol="0" anchor="ctr"/>
-          <a:lstStyle/>
-          <a:p>
-            <a:pPr marL="0" indent="0">
-              <a:buNone/>
-            </a:pPr>
-            <a:r>
-              <a:rPr lang="en-US" sz="1900" b="1" dirty="0">
-                <a:solidFill>
-                  <a:srgbClr val="2563EB"/>
-                </a:solidFill>
-                <a:latin typeface="Calibri" pitchFamily="34" charset="0"/>
-                <a:ea typeface="Calibri" pitchFamily="34" charset="-122"/>
-                <a:cs typeface="Calibri" pitchFamily="34" charset="-120"/>
-              </a:rPr>
-              <a:t>Vídeo gravado</a:t>
-            </a:r>
-            <a:endParaRPr lang="en-US" sz="1900" dirty="0"/>
-          </a:p>
-        </p:txBody>
-      </p:sp>
-      <p:sp>
-        <p:nvSpPr>
-          <p:cNvPr id="8" name="Text 6"/>
-          <p:cNvSpPr/>
-          <p:nvPr/>
-        </p:nvSpPr>
-        <p:spPr>
-          <a:xfrm>
-            <a:off x="914400" y="2788920"/>
-            <a:ext cx="4663440" cy="1463040"/>
-          </a:xfrm>
-          <a:prstGeom prst="rect">
-            <a:avLst/>
-          </a:prstGeom>
-          <a:noFill/>
-          <a:ln/>
-        </p:spPr>
-        <p:txBody>
-          <a:bodyPr wrap="square" lIns="0" tIns="0" rIns="0" bIns="0" rtlCol="0" anchor="ctr"/>
-          <a:lstStyle/>
-          <a:p>
-            <a:pPr marL="0" indent="0">
-              <a:buNone/>
-            </a:pPr>
-            <a:r>
-              <a:rPr lang="en-US" sz="1350" dirty="0">
-                <a:solidFill>
-                  <a:srgbClr val="1E293B"/>
-                </a:solidFill>
-                <a:latin typeface="Calibri" pitchFamily="34" charset="0"/>
-                <a:ea typeface="Calibri" pitchFamily="34" charset="-122"/>
-                <a:cs typeface="Calibri" pitchFamily="34" charset="-120"/>
-              </a:rPr>
-              <a:t>Gravação da demonstração completa seguindo o mesmo roteiro do live coding (docs/ROTEIRO-DEMO.md), disponível offline em pen drive e na nuvem.</a:t>
-            </a:r>
-            <a:endParaRPr lang="en-US" sz="1350" dirty="0"/>
-          </a:p>
-        </p:txBody>
-      </p:sp>
-      <p:sp>
-        <p:nvSpPr>
-          <p:cNvPr id="9" name="Shape 7"/>
-          <p:cNvSpPr/>
-          <p:nvPr/>
-        </p:nvSpPr>
-        <p:spPr>
-          <a:xfrm>
-            <a:off x="6172200" y="1920240"/>
-            <a:ext cx="5440680" cy="3291840"/>
-          </a:xfrm>
-          <a:prstGeom prst="roundRect">
-            <a:avLst>
-              <a:gd name="adj" fmla="val 2500"/>
-            </a:avLst>
-          </a:prstGeom>
-          <a:solidFill>
-            <a:srgbClr val="F1F5F9"/>
-          </a:solidFill>
-          <a:ln w="12700">
-            <a:solidFill>
-              <a:srgbClr val="E2E8F0"/>
-            </a:solidFill>
-            <a:prstDash val="solid"/>
-          </a:ln>
-        </p:spPr>
-        <p:txBody>
-          <a:bodyPr/>
-          <a:lstStyle/>
-          <a:p>
-            <a:endParaRPr lang="pt-BR"/>
-          </a:p>
-        </p:txBody>
-      </p:sp>
-      <p:sp>
-        <p:nvSpPr>
-          <p:cNvPr id="10" name="Text 8"/>
-          <p:cNvSpPr/>
-          <p:nvPr/>
-        </p:nvSpPr>
-        <p:spPr>
-          <a:xfrm>
-            <a:off x="6537960" y="2240280"/>
-            <a:ext cx="4754880" cy="457200"/>
-          </a:xfrm>
-          <a:prstGeom prst="rect">
-            <a:avLst/>
-          </a:prstGeom>
-          <a:noFill/>
-          <a:ln/>
-        </p:spPr>
-        <p:txBody>
-          <a:bodyPr wrap="square" lIns="0" tIns="0" rIns="0" bIns="0" rtlCol="0" anchor="ctr"/>
-          <a:lstStyle/>
-          <a:p>
-            <a:pPr marL="0" indent="0">
-              <a:buNone/>
-            </a:pPr>
-            <a:r>
-              <a:rPr lang="en-US" sz="1900" b="1" dirty="0">
-                <a:solidFill>
-                  <a:srgbClr val="2563EB"/>
-                </a:solidFill>
-                <a:latin typeface="Calibri" pitchFamily="34" charset="0"/>
-                <a:ea typeface="Calibri" pitchFamily="34" charset="-122"/>
-                <a:cs typeface="Calibri" pitchFamily="34" charset="-120"/>
-              </a:rPr>
-              <a:t>Projeto no repositório</a:t>
-            </a:r>
-            <a:endParaRPr lang="en-US" sz="1900" dirty="0"/>
-          </a:p>
-        </p:txBody>
-      </p:sp>
-      <p:sp>
-        <p:nvSpPr>
-          <p:cNvPr id="11" name="Text 9"/>
-          <p:cNvSpPr/>
-          <p:nvPr/>
-        </p:nvSpPr>
-        <p:spPr>
-          <a:xfrm>
-            <a:off x="6537960" y="2788920"/>
-            <a:ext cx="4754880" cy="1005840"/>
-          </a:xfrm>
-          <a:prstGeom prst="rect">
-            <a:avLst/>
-          </a:prstGeom>
-          <a:noFill/>
-          <a:ln/>
-        </p:spPr>
-        <p:txBody>
-          <a:bodyPr wrap="square" lIns="0" tIns="0" rIns="0" bIns="0" rtlCol="0" anchor="ctr"/>
-          <a:lstStyle/>
-          <a:p>
-            <a:pPr marL="0" indent="0">
-              <a:buNone/>
-            </a:pPr>
-            <a:r>
-              <a:rPr lang="en-US" sz="1350" dirty="0">
-                <a:solidFill>
-                  <a:srgbClr val="1E293B"/>
-                </a:solidFill>
-                <a:latin typeface="Calibri" pitchFamily="34" charset="0"/>
-                <a:ea typeface="Calibri" pitchFamily="34" charset="-122"/>
-                <a:cs typeface="Calibri" pitchFamily="34" charset="-120"/>
-              </a:rPr>
-              <a:t>Código completo e testado, commitado no Git. Qualquer máquina com Node.js reproduz a demo em dois comandos:</a:t>
-            </a:r>
-            <a:endParaRPr lang="en-US" sz="1350" dirty="0"/>
-          </a:p>
-        </p:txBody>
-      </p:sp>
-      <p:sp>
-        <p:nvSpPr>
-          <p:cNvPr id="12" name="Shape 10"/>
-          <p:cNvSpPr/>
-          <p:nvPr/>
-        </p:nvSpPr>
-        <p:spPr>
-          <a:xfrm>
-            <a:off x="6537960" y="3977640"/>
-            <a:ext cx="4709160" cy="914400"/>
-          </a:xfrm>
-          <a:prstGeom prst="roundRect">
-            <a:avLst>
-              <a:gd name="adj" fmla="val 8000"/>
-            </a:avLst>
-          </a:prstGeom>
-          <a:solidFill>
-            <a:srgbClr val="0F172A"/>
-          </a:solidFill>
-          <a:ln/>
-        </p:spPr>
-        <p:txBody>
-          <a:bodyPr/>
-          <a:lstStyle/>
-          <a:p>
-            <a:endParaRPr lang="pt-BR"/>
-          </a:p>
-        </p:txBody>
-      </p:sp>
-      <p:sp>
-        <p:nvSpPr>
-          <p:cNvPr id="13" name="Text 11"/>
-          <p:cNvSpPr/>
-          <p:nvPr/>
-        </p:nvSpPr>
-        <p:spPr>
-          <a:xfrm>
-            <a:off x="6766560" y="4142232"/>
-            <a:ext cx="4251960" cy="585216"/>
-          </a:xfrm>
-          <a:prstGeom prst="rect">
-            <a:avLst/>
-          </a:prstGeom>
-          <a:noFill/>
-          <a:ln/>
-        </p:spPr>
-        <p:txBody>
-          <a:bodyPr wrap="square" lIns="0" tIns="0" rIns="0" bIns="0" rtlCol="0" anchor="t"/>
-          <a:lstStyle/>
-          <a:p>
-            <a:pPr marL="0" indent="0">
-              <a:lnSpc>
-                <a:spcPct val="115000"/>
-              </a:lnSpc>
-              <a:buNone/>
-            </a:pPr>
-            <a:r>
-              <a:rPr lang="en-US" sz="1300" dirty="0">
-                <a:solidFill>
-                  <a:srgbClr val="E2E8F0"/>
-                </a:solidFill>
-                <a:latin typeface="Courier New" pitchFamily="34" charset="0"/>
-                <a:ea typeface="Courier New" pitchFamily="34" charset="-122"/>
-                <a:cs typeface="Courier New" pitchFamily="34" charset="-120"/>
-              </a:rPr>
-              <a:t>$ npm install</a:t>
-            </a:r>
-            <a:endParaRPr lang="en-US" sz="1300" dirty="0"/>
-          </a:p>
-          <a:p>
-            <a:pPr marL="0" indent="0">
-              <a:lnSpc>
-                <a:spcPct val="115000"/>
-              </a:lnSpc>
-              <a:buNone/>
-            </a:pPr>
-            <a:r>
-              <a:rPr lang="en-US" sz="1300" dirty="0">
-                <a:solidFill>
-                  <a:srgbClr val="E2E8F0"/>
-                </a:solidFill>
-                <a:latin typeface="Courier New" pitchFamily="34" charset="0"/>
-                <a:ea typeface="Courier New" pitchFamily="34" charset="-122"/>
-                <a:cs typeface="Courier New" pitchFamily="34" charset="-120"/>
-              </a:rPr>
-              <a:t>$ npm run dev</a:t>
-            </a:r>
-            <a:endParaRPr lang="en-US" sz="1300" dirty="0"/>
-          </a:p>
-        </p:txBody>
-      </p:sp>
-      <p:sp>
-        <p:nvSpPr>
-          <p:cNvPr id="14" name="Text 12"/>
-          <p:cNvSpPr/>
-          <p:nvPr/>
-        </p:nvSpPr>
-        <p:spPr>
-          <a:xfrm>
-            <a:off x="548640" y="5577840"/>
-            <a:ext cx="11064240" cy="457200"/>
-          </a:xfrm>
-          <a:prstGeom prst="rect">
-            <a:avLst/>
-          </a:prstGeom>
-          <a:noFill/>
-          <a:ln/>
-        </p:spPr>
-        <p:txBody>
-          <a:bodyPr wrap="square" lIns="0" tIns="0" rIns="0" bIns="0" rtlCol="0" anchor="ctr"/>
-          <a:lstStyle/>
-          <a:p>
-            <a:pPr marL="0" indent="0">
-              <a:buNone/>
-            </a:pPr>
-            <a:r>
-              <a:rPr lang="en-US" sz="1300" i="1" dirty="0">
-                <a:solidFill>
-                  <a:srgbClr val="64748B"/>
-                </a:solidFill>
-                <a:latin typeface="Calibri" pitchFamily="34" charset="0"/>
-                <a:ea typeface="Calibri" pitchFamily="34" charset="-122"/>
-                <a:cs typeface="Calibri" pitchFamily="34" charset="-120"/>
-              </a:rPr>
-              <a:t>Build de produção validado antes da apresentação (npm run build sem erros).</a:t>
-            </a:r>
-            <a:endParaRPr lang="en-US" sz="1300" dirty="0"/>
-          </a:p>
-        </p:txBody>
-      </p:sp>
-    </p:spTree>
-  </p:cSld>
-  <p:clrMapOvr>
-    <a:masterClrMapping/>
-  </p:clrMapOvr>
-</p:sld>
-</file>
-
-<file path=ppt/slides/slide12.xml><?xml version="1.0" encoding="utf-8"?>
 <p:sld xmlns:a="http://schemas.openxmlformats.org/drawingml/2006/main" xmlns:r="http://schemas.openxmlformats.org/officeDocument/2006/relationships" xmlns:p="http://schemas.openxmlformats.org/presentationml/2006/main">
   <p:cSld name="Slide 12">
     <p:bg>

</xml_diff>